<commit_message>
Fix 49 failing tests for Vercel deployment
</commit_message>
<xml_diff>
--- a/docs/test/golden-outputs/p3-seocho-r3/captures/seocho_basic.pptx
+++ b/docs/test/golden-outputs/p3-seocho-r3/captures/seocho_basic.pptx
@@ -2110,7 +2110,7 @@
                 <a:ea typeface="맑은 고딕" pitchFamily="34" charset="-122"/>
                 <a:cs typeface="맑은 고딕" pitchFamily="34" charset="-120"/>
               </a:rPr>
-              <a:t>2026.09.22  |  담당자  |  CREDEAL</a:t>
+              <a:t>2026.09.23  |  담당자  |  CREDEAL</a:t>
             </a:r>
             <a:endParaRPr lang="en-US" sz="900" dirty="0"/>
           </a:p>
@@ -8661,8 +8661,7 @@
                 <a:gridCol w="749808"/>
                 <a:gridCol w="658368"/>
                 <a:gridCol w="658368"/>
-                <a:gridCol w="658368"/>
-                <a:gridCol w="502920"/>
+                <a:gridCol w="1161288"/>
               </a:tblGrid>
               <a:tr h="320040">
                 <a:tc>
@@ -9046,67 +9045,6 @@
                           </a:solidFill>
                         </a:rPr>
                         <a:t>월세(만원)</a:t>
-                      </a:r>
-                      <a:endParaRPr lang="en-US" sz="1000" dirty="0"/>
-                    </a:p>
-                  </a:txBody>
-                  <a:tcPr marL="91440" marR="91440" marT="45720" marB="45720" anchor="ctr">
-                    <a:lnL w="12700" cap="flat" cmpd="sng" algn="ctr">
-                      <a:solidFill>
-                        <a:srgbClr val="CBD5E0"/>
-                      </a:solidFill>
-                      <a:prstDash val="solid"/>
-                      <a:round/>
-                      <a:headEnd type="none" w="med" len="med"/>
-                      <a:tailEnd type="none" w="med" len="med"/>
-                    </a:lnL>
-                    <a:lnR w="12700" cap="flat" cmpd="sng" algn="ctr">
-                      <a:solidFill>
-                        <a:srgbClr val="CBD5E0"/>
-                      </a:solidFill>
-                      <a:prstDash val="solid"/>
-                      <a:round/>
-                      <a:headEnd type="none" w="med" len="med"/>
-                      <a:tailEnd type="none" w="med" len="med"/>
-                    </a:lnR>
-                    <a:lnT w="12700" cap="flat" cmpd="sng" algn="ctr">
-                      <a:solidFill>
-                        <a:srgbClr val="CBD5E0"/>
-                      </a:solidFill>
-                      <a:prstDash val="solid"/>
-                      <a:round/>
-                      <a:headEnd type="none" w="med" len="med"/>
-                      <a:tailEnd type="none" w="med" len="med"/>
-                    </a:lnT>
-                    <a:lnB w="12700" cap="flat" cmpd="sng" algn="ctr">
-                      <a:solidFill>
-                        <a:srgbClr val="CBD5E0"/>
-                      </a:solidFill>
-                      <a:prstDash val="solid"/>
-                      <a:round/>
-                      <a:headEnd type="none" w="med" len="med"/>
-                      <a:tailEnd type="none" w="med" len="med"/>
-                    </a:lnB>
-                    <a:solidFill>
-                      <a:srgbClr val="132A3A"/>
-                    </a:solidFill>
-                  </a:tcPr>
-                </a:tc>
-                <a:tc>
-                  <a:txBody>
-                    <a:bodyPr/>
-                    <a:lstStyle/>
-                    <a:p>
-                      <a:pPr algn="ctr" indent="0" marL="0">
-                        <a:buNone/>
-                      </a:pPr>
-                      <a:r>
-                        <a:rPr lang="en-US" sz="1000" b="1" dirty="0">
-                          <a:solidFill>
-                            <a:srgbClr val="FFFFFF"/>
-                          </a:solidFill>
-                        </a:rPr>
-                        <a:t>관리비(만원)</a:t>
                       </a:r>
                       <a:endParaRPr lang="en-US" sz="1000" dirty="0"/>
                     </a:p>
@@ -9829,17 +9767,6 @@
                       <a:pPr algn="ctr" indent="0" marL="0">
                         <a:buNone/>
                       </a:pPr>
-                      <a:r>
-                        <a:rPr lang="en-US" sz="850" dirty="0">
-                          <a:solidFill>
-                            <a:srgbClr val="2B2B2B"/>
-                          </a:solidFill>
-                          <a:latin typeface="맑은 고딕" pitchFamily="34" charset="0"/>
-                          <a:ea typeface="맑은 고딕" pitchFamily="34" charset="-122"/>
-                          <a:cs typeface="맑은 고딕" pitchFamily="34" charset="-120"/>
-                        </a:rPr>
-                        <a:t>-</a:t>
-                      </a:r>
                       <a:endParaRPr lang="en-US" sz="850" dirty="0">
                         <a:latin typeface="맑은 고딕" charset="0"/>
                         <a:ea typeface="맑은 고딕" charset="0"/>
@@ -10500,17 +10427,6 @@
                       <a:pPr algn="ctr" indent="0" marL="0">
                         <a:buNone/>
                       </a:pPr>
-                      <a:r>
-                        <a:rPr lang="en-US" sz="850" dirty="0">
-                          <a:solidFill>
-                            <a:srgbClr val="2B2B2B"/>
-                          </a:solidFill>
-                          <a:latin typeface="맑은 고딕" pitchFamily="34" charset="0"/>
-                          <a:ea typeface="맑은 고딕" pitchFamily="34" charset="-122"/>
-                          <a:cs typeface="맑은 고딕" pitchFamily="34" charset="-120"/>
-                        </a:rPr>
-                        <a:t>-</a:t>
-                      </a:r>
                       <a:endParaRPr lang="en-US" sz="850" dirty="0">
                         <a:latin typeface="맑은 고딕" charset="0"/>
                         <a:ea typeface="맑은 고딕" charset="0"/>
@@ -11180,7 +11096,7 @@
                           <a:ea typeface="맑은 고딕" pitchFamily="34" charset="-122"/>
                           <a:cs typeface="맑은 고딕" pitchFamily="34" charset="-120"/>
                         </a:rPr>
-                        <a:t>-</a:t>
+                        <a:t>공실</a:t>
                       </a:r>
                       <a:endParaRPr lang="en-US" sz="850" dirty="0">
                         <a:latin typeface="맑은 고딕" charset="0"/>
@@ -11239,17 +11155,6 @@
                       <a:pPr algn="ctr" indent="0" marL="0">
                         <a:buNone/>
                       </a:pPr>
-                      <a:r>
-                        <a:rPr lang="en-US" sz="850" b="1" dirty="0">
-                          <a:solidFill>
-                            <a:srgbClr val="B05A2E"/>
-                          </a:solidFill>
-                          <a:latin typeface="맑은 고딕" pitchFamily="34" charset="0"/>
-                          <a:ea typeface="맑은 고딕" pitchFamily="34" charset="-122"/>
-                          <a:cs typeface="맑은 고딕" pitchFamily="34" charset="-120"/>
-                        </a:rPr>
-                        <a:t>공실</a:t>
-                      </a:r>
                       <a:endParaRPr lang="en-US" sz="850" dirty="0">
                         <a:latin typeface="맑은 고딕" charset="0"/>
                         <a:ea typeface="맑은 고딕" charset="0"/>
@@ -11853,17 +11758,6 @@
                       <a:pPr algn="ctr" indent="0" marL="0">
                         <a:buNone/>
                       </a:pPr>
-                      <a:r>
-                        <a:rPr lang="en-US" sz="850" dirty="0">
-                          <a:solidFill>
-                            <a:srgbClr val="2B2B2B"/>
-                          </a:solidFill>
-                          <a:latin typeface="맑은 고딕" pitchFamily="34" charset="0"/>
-                          <a:ea typeface="맑은 고딕" pitchFamily="34" charset="-122"/>
-                          <a:cs typeface="맑은 고딕" pitchFamily="34" charset="-120"/>
-                        </a:rPr>
-                        <a:t>-</a:t>
-                      </a:r>
                       <a:endParaRPr lang="en-US" sz="850" dirty="0">
                         <a:latin typeface="맑은 고딕" charset="0"/>
                         <a:ea typeface="맑은 고딕" charset="0"/>
@@ -12533,7 +12427,7 @@
                           <a:ea typeface="맑은 고딕" pitchFamily="34" charset="-122"/>
                           <a:cs typeface="맑은 고딕" pitchFamily="34" charset="-120"/>
                         </a:rPr>
-                        <a:t>-</a:t>
+                        <a:t>공실</a:t>
                       </a:r>
                       <a:endParaRPr lang="en-US" sz="850" dirty="0">
                         <a:latin typeface="맑은 고딕" charset="0"/>
@@ -12592,17 +12486,6 @@
                       <a:pPr algn="ctr" indent="0" marL="0">
                         <a:buNone/>
                       </a:pPr>
-                      <a:r>
-                        <a:rPr lang="en-US" sz="850" b="1" dirty="0">
-                          <a:solidFill>
-                            <a:srgbClr val="B05A2E"/>
-                          </a:solidFill>
-                          <a:latin typeface="맑은 고딕" pitchFamily="34" charset="0"/>
-                          <a:ea typeface="맑은 고딕" pitchFamily="34" charset="-122"/>
-                          <a:cs typeface="맑은 고딕" pitchFamily="34" charset="-120"/>
-                        </a:rPr>
-                        <a:t>공실</a:t>
-                      </a:r>
                       <a:endParaRPr lang="en-US" sz="850" dirty="0">
                         <a:latin typeface="맑은 고딕" charset="0"/>
                         <a:ea typeface="맑은 고딕" charset="0"/>
@@ -13215,7 +13098,7 @@
                           <a:ea typeface="맑은 고딕" pitchFamily="34" charset="-122"/>
                           <a:cs typeface="맑은 고딕" pitchFamily="34" charset="-120"/>
                         </a:rPr>
-                        <a:t>-</a:t>
+                        <a:t>공실</a:t>
                       </a:r>
                       <a:endParaRPr lang="en-US" sz="850" dirty="0">
                         <a:latin typeface="맑은 고딕" charset="0"/>
@@ -13274,17 +13157,6 @@
                       <a:pPr algn="ctr" indent="0" marL="0">
                         <a:buNone/>
                       </a:pPr>
-                      <a:r>
-                        <a:rPr lang="en-US" sz="850" b="1" dirty="0">
-                          <a:solidFill>
-                            <a:srgbClr val="B05A2E"/>
-                          </a:solidFill>
-                          <a:latin typeface="맑은 고딕" pitchFamily="34" charset="0"/>
-                          <a:ea typeface="맑은 고딕" pitchFamily="34" charset="-122"/>
-                          <a:cs typeface="맑은 고딕" pitchFamily="34" charset="-120"/>
-                        </a:rPr>
-                        <a:t>공실</a:t>
-                      </a:r>
                       <a:endParaRPr lang="en-US" sz="850" dirty="0">
                         <a:latin typeface="맑은 고딕" charset="0"/>
                         <a:ea typeface="맑은 고딕" charset="0"/>
@@ -13888,17 +13760,6 @@
                       <a:pPr algn="ctr" indent="0" marL="0">
                         <a:buNone/>
                       </a:pPr>
-                      <a:r>
-                        <a:rPr lang="en-US" sz="850" dirty="0">
-                          <a:solidFill>
-                            <a:srgbClr val="2B2B2B"/>
-                          </a:solidFill>
-                          <a:latin typeface="맑은 고딕" pitchFamily="34" charset="0"/>
-                          <a:ea typeface="맑은 고딕" pitchFamily="34" charset="-122"/>
-                          <a:cs typeface="맑은 고딕" pitchFamily="34" charset="-120"/>
-                        </a:rPr>
-                        <a:t>-</a:t>
-                      </a:r>
                       <a:endParaRPr lang="en-US" sz="850" dirty="0">
                         <a:latin typeface="맑은 고딕" charset="0"/>
                         <a:ea typeface="맑은 고딕" charset="0"/>
@@ -14559,17 +14420,6 @@
                       <a:pPr algn="ctr" indent="0" marL="0">
                         <a:buNone/>
                       </a:pPr>
-                      <a:r>
-                        <a:rPr lang="en-US" sz="850" dirty="0">
-                          <a:solidFill>
-                            <a:srgbClr val="2B2B2B"/>
-                          </a:solidFill>
-                          <a:latin typeface="맑은 고딕" pitchFamily="34" charset="0"/>
-                          <a:ea typeface="맑은 고딕" pitchFamily="34" charset="-122"/>
-                          <a:cs typeface="맑은 고딕" pitchFamily="34" charset="-120"/>
-                        </a:rPr>
-                        <a:t>-</a:t>
-                      </a:r>
                       <a:endParaRPr lang="en-US" sz="850" dirty="0">
                         <a:latin typeface="맑은 고딕" charset="0"/>
                         <a:ea typeface="맑은 고딕" charset="0"/>

</xml_diff>